<commit_message>
Makale 2: add DOI to bottom-right of the cover slide
Co-Authored-By: Claude Sonnet 5.5 <noreply@anthropic.com>
Claude-Session: https://claude.ai/code/session_01TyFKmLJqyxNygHvjK9ydxU
</commit_message>
<xml_diff>
--- a/Özel Eğitim Öğretmenlerinin Uygulamalı Davranış Analizi Kapsamında Sosyal Becerilere Yönelik Görüşlerinin İncelenmesi.pptx
+++ b/Özel Eğitim Öğretmenlerinin Uygulamalı Davranış Analizi Kapsamında Sosyal Becerilere Yönelik Görüşlerinin İncelenmesi.pptx
@@ -4187,6 +4187,48 @@
           <a:lstStyle/>
           <a:p>
             <a:pPr algn="ctr"/>
+          </a:p>
+        </p:txBody>
+      </p:sp>
+      <p:sp>
+        <p:nvSpPr>
+          <p:cNvPr id="8" name="TextBox 7"/>
+          <p:cNvSpPr txBox="1"/>
+          <p:nvPr/>
+        </p:nvSpPr>
+        <p:spPr>
+          <a:xfrm>
+            <a:off x="3108960" y="6309360"/>
+            <a:ext cx="5212080" cy="365760"/>
+          </a:xfrm>
+          <a:prstGeom prst="rect">
+            <a:avLst/>
+          </a:prstGeom>
+          <a:noFill/>
+        </p:spPr>
+        <p:txBody>
+          <a:bodyPr wrap="square" anchor="ctr">
+            <a:spAutoFit/>
+          </a:bodyPr>
+          <a:lstStyle/>
+          <a:p>
+            <a:pPr algn="r"/>
+            <a:r>
+              <a:rPr sz="1300">
+                <a:solidFill>
+                  <a:srgbClr val="000000"/>
+                </a:solidFill>
+                <a:latin typeface="Times New Roman"/>
+                <a:hlinkClick r:id="rId2">
+                  <a:extLst>
+                    <a:ext uri="{A12FA001-AC4F-418D-AE19-62706E023703}">
+                      <ahyp:hlinkClr xmlns:ahyp="http://schemas.microsoft.com/office/drawing/2018/hyperlinkcolor" val="tx"/>
+                    </a:ext>
+                  </a:extLst>
+                </a:hlinkClick>
+              </a:rPr>
+              <a:t>DOI: https://doi.org/10.29329/baflas.2025.1404.2</a:t>
+            </a:r>
           </a:p>
         </p:txBody>
       </p:sp>

</xml_diff>